<commit_message>
chore: add codex_output artifacts
</commit_message>
<xml_diff>
--- a/codex_output/04_moe_distribute_dispatch_v2代码分析/02_moe_distribute_dispatch_v2_A5_code_analysis_summary.pptx
+++ b/codex_output/04_moe_distribute_dispatch_v2代码分析/02_moe_distribute_dispatch_v2_A5_code_analysis_summary.pptx
@@ -2,24 +2,24 @@
 <file path=ppt/presentation.xml><?xml version="1.0" encoding="utf-8"?>
 <p:presentation xmlns:p="http://schemas.openxmlformats.org/presentationml/2006/main">
   <p:sldMasterIdLst>
-    <p:sldMasterId xmlns:r="http://schemas.openxmlformats.org/officeDocument/2006/relationships" id="2147483648" r:id="R71506630f339423b"/>
+    <p:sldMasterId xmlns:r="http://schemas.openxmlformats.org/officeDocument/2006/relationships" id="2147483648" r:id="R1bcbdda882534218"/>
   </p:sldMasterIdLst>
   <p:notesMasterIdLst>
-    <p:notesMasterId xmlns:r="http://schemas.openxmlformats.org/officeDocument/2006/relationships" r:id="R003aa70750e540db"/>
+    <p:notesMasterId xmlns:r="http://schemas.openxmlformats.org/officeDocument/2006/relationships" r:id="R701f003b0f674ed6"/>
   </p:notesMasterIdLst>
   <p:sldIdLst>
-    <p:sldId xmlns:r="http://schemas.openxmlformats.org/officeDocument/2006/relationships" id="256" r:id="R38deb51c81044da5"/>
-    <p:sldId xmlns:r="http://schemas.openxmlformats.org/officeDocument/2006/relationships" id="257" r:id="Rac4052d2a1a444c7"/>
-    <p:sldId xmlns:r="http://schemas.openxmlformats.org/officeDocument/2006/relationships" id="258" r:id="R40c6132b9f544ecf"/>
-    <p:sldId xmlns:r="http://schemas.openxmlformats.org/officeDocument/2006/relationships" id="259" r:id="Ra05a8c962f174303"/>
-    <p:sldId xmlns:r="http://schemas.openxmlformats.org/officeDocument/2006/relationships" id="260" r:id="R55611633da4d4ab8"/>
-    <p:sldId xmlns:r="http://schemas.openxmlformats.org/officeDocument/2006/relationships" id="261" r:id="R31eb3e11b4e64364"/>
-    <p:sldId xmlns:r="http://schemas.openxmlformats.org/officeDocument/2006/relationships" id="262" r:id="Ra560550bc05e4231"/>
-    <p:sldId xmlns:r="http://schemas.openxmlformats.org/officeDocument/2006/relationships" id="263" r:id="R607bb4cf1ca44a7e"/>
-    <p:sldId xmlns:r="http://schemas.openxmlformats.org/officeDocument/2006/relationships" id="264" r:id="R721b4f9fda974fb4"/>
-    <p:sldId xmlns:r="http://schemas.openxmlformats.org/officeDocument/2006/relationships" id="265" r:id="R1c3f492791d1486a"/>
-    <p:sldId xmlns:r="http://schemas.openxmlformats.org/officeDocument/2006/relationships" id="266" r:id="R7e69e97ebae949d2"/>
-    <p:sldId xmlns:r="http://schemas.openxmlformats.org/officeDocument/2006/relationships" id="267" r:id="R6cc8b634cd26422f"/>
+    <p:sldId xmlns:r="http://schemas.openxmlformats.org/officeDocument/2006/relationships" id="256" r:id="Rcfdaa9d36ecb4694"/>
+    <p:sldId xmlns:r="http://schemas.openxmlformats.org/officeDocument/2006/relationships" id="257" r:id="Rf5a6a152316f4c3e"/>
+    <p:sldId xmlns:r="http://schemas.openxmlformats.org/officeDocument/2006/relationships" id="258" r:id="R0aafed91e55e473c"/>
+    <p:sldId xmlns:r="http://schemas.openxmlformats.org/officeDocument/2006/relationships" id="259" r:id="Rfa65a7365f37421d"/>
+    <p:sldId xmlns:r="http://schemas.openxmlformats.org/officeDocument/2006/relationships" id="260" r:id="Rbb903a15949e47b8"/>
+    <p:sldId xmlns:r="http://schemas.openxmlformats.org/officeDocument/2006/relationships" id="261" r:id="Rfc530c8c230547d8"/>
+    <p:sldId xmlns:r="http://schemas.openxmlformats.org/officeDocument/2006/relationships" id="262" r:id="R59881e0501c24de9"/>
+    <p:sldId xmlns:r="http://schemas.openxmlformats.org/officeDocument/2006/relationships" id="263" r:id="R6279e45264c94921"/>
+    <p:sldId xmlns:r="http://schemas.openxmlformats.org/officeDocument/2006/relationships" id="264" r:id="Ra2f21752a96b4389"/>
+    <p:sldId xmlns:r="http://schemas.openxmlformats.org/officeDocument/2006/relationships" id="265" r:id="Rba8bfd46ea704783"/>
+    <p:sldId xmlns:r="http://schemas.openxmlformats.org/officeDocument/2006/relationships" id="266" r:id="R08d1e88f552649e5"/>
+    <p:sldId xmlns:r="http://schemas.openxmlformats.org/officeDocument/2006/relationships" id="267" r:id="R9ed31bf9a18945b1"/>
   </p:sldIdLst>
   <p:sldSz cx="12192000" cy="6858000"/>
   <p:notesSz cx="6858000" cy="9144000"/>
@@ -1338,7 +1338,7 @@
   </p:cSld>
   <p:clrMap bg1="lt1" tx1="dk1" bg2="lt2" tx2="dk2" accent1="accent1" accent2="accent2" accent3="accent3" accent4="accent4" accent5="accent5" accent6="accent6" hlink="hlink" folHlink="folHlink"/>
   <p:sldLayoutIdLst>
-    <p:sldLayoutId xmlns:r="http://schemas.openxmlformats.org/officeDocument/2006/relationships" id="2147483649" r:id="Re38521afd4fc43cb"/>
+    <p:sldLayoutId xmlns:r="http://schemas.openxmlformats.org/officeDocument/2006/relationships" id="2147483649" r:id="R11ec36f3557f472c"/>
   </p:sldLayoutIdLst>
   <p:txStyles>
     <p:titleStyle>
@@ -3128,7 +3128,7 @@
                 <a:ea typeface="Aptos"/>
                 <a:cs typeface="Aptos"/>
               </a:rPr>
-              <a:t>HostKfc</a:t>
+              <a:t>CCU 边界</a:t>
             </a:r>
           </a:p>
         </p:txBody>
@@ -3185,7 +3185,7 @@
                 <a:ea typeface="Aptos"/>
                 <a:cs typeface="Aptos"/>
               </a:rPr>
-              <a:t>arch35 HostKfc 逻辑完整但当前主 kernel 未直接派发，需用编译产物确认。</a:t>
+              <a:t>CCU 只覆盖 EP-only、tp=1、HalfAlltoAllV；不是 MTE/window/fullmesh 的统一替代。</a:t>
             </a:r>
           </a:p>
         </p:txBody>
@@ -3312,7 +3312,7 @@
                 <a:ea typeface="Aptos"/>
                 <a:cs typeface="Aptos"/>
               </a:rPr>
-              <a:t>HCCL window</a:t>
+              <a:t>资源约束</a:t>
             </a:r>
           </a:p>
         </p:txBody>
@@ -3369,7 +3369,7 @@
                 <a:ea typeface="Aptos"/>
                 <a:cs typeface="Aptos"/>
               </a:rPr>
-              <a:t>CheckCommAttrs 对 window 容量按 HCCL_BUFFSIZE*2 检查；量化 payload 对齐需与 perTokenCommSize_ 复核。</a:t>
+              <a:t>CCU 依赖 ccu server、XN/CKE 与双缓冲 HCCL window；MTE 是独立资源模型。</a:t>
             </a:r>
           </a:p>
         </p:txBody>
@@ -7548,7 +7548,7 @@
                 <a:ea typeface="Aptos"/>
                 <a:cs typeface="Aptos"/>
               </a:rPr>
-              <a:t>comm_alg=ccu 走 CCU 专用链路；空/fullmesh_v1/fullmesh_v2 走 MTE/window 链路。</a:t>
+              <a:t>A5 实际三分支：ccu 走 EP-only CCU；空/fullmesh_v1 走 MTE 默认；fullmesh_v2 走 MTE FullMesh。</a:t>
             </a:r>
           </a:p>
         </p:txBody>
@@ -7697,7 +7697,7 @@
                 <a:ea typeface="Aptos"/>
                 <a:cs typeface="Aptos"/>
               </a:rPr>
-              <a:t>A5 non-ccu 对外可叫 V2，但 API/graph 侧会转 Inner V3 或 V2-&gt;V3 节点。</a:t>
+              <a:t>CCU 是专用加速而非统一替代；MTE 两分支承接 V3/context、兼容与 fullmesh_v2。</a:t>
             </a:r>
           </a:p>
         </p:txBody>
@@ -9329,7 +9329,7 @@
                 <a:ea typeface="Aptos"/>
                 <a:cs typeface="Aptos"/>
               </a:rPr>
-              <a:t>同一个算子在 API、graph、tiling、kernel 的选择条件并不完全相同。</a:t>
+              <a:t>A5 分支由 comm_alg、V3/context、FullMesh tiling key 和 CCU server 资源共同决定。</a:t>
             </a:r>
           </a:p>
         </p:txBody>
@@ -10872,7 +10872,7 @@
                 <a:ea typeface="Aptos"/>
                 <a:cs typeface="Aptos"/>
               </a:rPr>
-              <a:t>空/fullmesh</a:t>
+              <a:t>空/fullmesh_v1/v2</a:t>
             </a:r>
           </a:p>
         </p:txBody>
@@ -10929,7 +10929,7 @@
                 <a:ea typeface="Aptos"/>
                 <a:cs typeface="Aptos"/>
               </a:rPr>
-              <a:t>A3 public tiling + ARCH=A5</a:t>
+              <a:t>空/fullmesh_v1 -&gt; no-fullmesh；fullmesh_v2 -&gt; FullMesh</a:t>
             </a:r>
           </a:p>
         </p:txBody>
@@ -11043,7 +11043,7 @@
                 <a:ea typeface="Aptos"/>
                 <a:cs typeface="Aptos"/>
               </a:rPr>
-              <a:t>ccu / MTE</a:t>
+              <a:t>ccu / non-ccu</a:t>
             </a:r>
           </a:p>
         </p:txBody>
@@ -11100,7 +11100,7 @@
                 <a:ea typeface="Aptos"/>
                 <a:cs typeface="Aptos"/>
               </a:rPr>
-              <a:t>A5 / V2 / FullMesh</a:t>
+              <a:t>ccu -&gt; A5；空/v1 -&gt; V2；v2 -&gt; FullMesh</a:t>
             </a:r>
           </a:p>
         </p:txBody>

</xml_diff>